<commit_message>
updating for pic: names and bold letters
</commit_message>
<xml_diff>
--- a/Docs/pics/Workflow_NADIA_ESP.pptx
+++ b/Docs/pics/Workflow_NADIA_ESP.pptx
@@ -676,42 +676,113 @@
             <a:prstDash val="solid"/>
           </a:ln>
         </p:spPr>
+        <p:txBody>
+          <a:bodyPr/>
+          <a:lstStyle/>
+          <a:p>
+            <a:endParaRPr lang="es-ES"/>
+          </a:p>
+        </p:txBody>
       </p:sp>
-      <p:sp>
-        <p:nvSpPr>
-          <p:cNvPr id="3" name="circle_1"/>
-          <p:cNvSpPr/>
+      <p:grpSp>
+        <p:nvGrpSpPr>
+          <p:cNvPr id="34" name="Group 33">
+            <a:extLst>
+              <a:ext uri="{FF2B5EF4-FFF2-40B4-BE49-F238E27FC236}">
+                <a16:creationId xmlns:a16="http://schemas.microsoft.com/office/drawing/2014/main" id="{75110255-6E3A-27DA-76DF-162B1E4FC3FD}"/>
+              </a:ext>
+            </a:extLst>
+          </p:cNvPr>
+          <p:cNvGrpSpPr/>
           <p:nvPr/>
-        </p:nvSpPr>
-        <p:spPr>
+        </p:nvGrpSpPr>
+        <p:grpSpPr>
           <a:xfrm>
-            <a:off x="201168" y="155448"/>
-            <a:ext cx="256032" cy="256032"/>
+            <a:off x="224365" y="155447"/>
+            <a:ext cx="395732" cy="404241"/>
+            <a:chOff x="201168" y="155448"/>
+            <a:chExt cx="256032" cy="256032"/>
           </a:xfrm>
-          <a:prstGeom prst="ellipse">
-            <a:avLst/>
-          </a:prstGeom>
-          <a:solidFill>
-            <a:srgbClr val="3A7D52"/>
-          </a:solidFill>
-          <a:ln w="12700">
+        </p:grpSpPr>
+        <p:sp>
+          <p:nvSpPr>
+            <p:cNvPr id="3" name="circle_1"/>
+            <p:cNvSpPr/>
+            <p:nvPr/>
+          </p:nvSpPr>
+          <p:spPr>
+            <a:xfrm>
+              <a:off x="201168" y="155448"/>
+              <a:ext cx="256032" cy="256032"/>
+            </a:xfrm>
+            <a:prstGeom prst="ellipse">
+              <a:avLst/>
+            </a:prstGeom>
             <a:solidFill>
               <a:srgbClr val="3A7D52"/>
             </a:solidFill>
-            <a:prstDash val="solid"/>
-          </a:ln>
-        </p:spPr>
-      </p:sp>
+            <a:ln w="12700">
+              <a:solidFill>
+                <a:srgbClr val="3A7D52"/>
+              </a:solidFill>
+              <a:prstDash val="solid"/>
+            </a:ln>
+          </p:spPr>
+          <p:txBody>
+            <a:bodyPr/>
+            <a:lstStyle/>
+            <a:p>
+              <a:endParaRPr lang="es-ES"/>
+            </a:p>
+          </p:txBody>
+        </p:sp>
+        <p:sp>
+          <p:nvSpPr>
+            <p:cNvPr id="4" name="label_1"/>
+            <p:cNvSpPr txBox="1"/>
+            <p:nvPr/>
+          </p:nvSpPr>
+          <p:spPr>
+            <a:xfrm>
+              <a:off x="201168" y="155448"/>
+              <a:ext cx="256032" cy="256032"/>
+            </a:xfrm>
+            <a:prstGeom prst="rect">
+              <a:avLst/>
+            </a:prstGeom>
+            <a:noFill/>
+            <a:ln/>
+          </p:spPr>
+          <p:txBody>
+            <a:bodyPr wrap="square" rtlCol="0" anchor="ctr"/>
+            <a:lstStyle/>
+            <a:p>
+              <a:pPr marL="0" indent="0" algn="ctr">
+                <a:buNone/>
+              </a:pPr>
+              <a:r>
+                <a:rPr lang="en-US" sz="2000" b="1" dirty="0">
+                  <a:solidFill>
+                    <a:srgbClr val="FFFFFF"/>
+                  </a:solidFill>
+                </a:rPr>
+                <a:t>1</a:t>
+              </a:r>
+              <a:endParaRPr lang="en-US" sz="2000" dirty="0"/>
+            </a:p>
+          </p:txBody>
+        </p:sp>
+      </p:grpSp>
       <p:sp>
         <p:nvSpPr>
-          <p:cNvPr id="4" name="label_1"/>
+          <p:cNvPr id="5" name="title_sec1"/>
           <p:cNvSpPr txBox="1"/>
           <p:nvPr/>
         </p:nvSpPr>
         <p:spPr>
           <a:xfrm>
-            <a:off x="201168" y="155448"/>
-            <a:ext cx="256032" cy="256032"/>
+            <a:off x="5421521" y="672783"/>
+            <a:ext cx="6200985" cy="452586"/>
           </a:xfrm>
           <a:prstGeom prst="rect">
             <a:avLst/>
@@ -723,43 +794,7 @@
           <a:bodyPr wrap="square" rtlCol="0" anchor="ctr"/>
           <a:lstStyle/>
           <a:p>
-            <a:pPr marL="0" indent="0" algn="ctr">
-              <a:buNone/>
-            </a:pPr>
-            <a:r>
-              <a:rPr lang="en-US" sz="1100" b="1" dirty="0">
-                <a:solidFill>
-                  <a:srgbClr val="FFFFFF"/>
-                </a:solidFill>
-              </a:rPr>
-              <a:t>1</a:t>
-            </a:r>
-            <a:endParaRPr lang="en-US" sz="1100" dirty="0"/>
-          </a:p>
-        </p:txBody>
-      </p:sp>
-      <p:sp>
-        <p:nvSpPr>
-          <p:cNvPr id="5" name="title_sec1"/>
-          <p:cNvSpPr txBox="1"/>
-          <p:nvPr/>
-        </p:nvSpPr>
-        <p:spPr>
-          <a:xfrm>
-            <a:off x="5046135" y="521208"/>
-            <a:ext cx="6200985" cy="731520"/>
-          </a:xfrm>
-          <a:prstGeom prst="rect">
-            <a:avLst/>
-          </a:prstGeom>
-          <a:noFill/>
-          <a:ln/>
-        </p:spPr>
-        <p:txBody>
-          <a:bodyPr wrap="square" rtlCol="0" anchor="ctr"/>
-          <a:lstStyle/>
-          <a:p>
-            <a:pPr marL="0" indent="0" algn="ctr">
+            <a:pPr marL="0" indent="0" algn="r">
               <a:buNone/>
             </a:pPr>
             <a:r>
@@ -768,21 +803,31 @@
                   <a:srgbClr val="2A6B42"/>
                 </a:solidFill>
               </a:rPr>
-              <a:t>Procesamiento de datos brutos</a:t>
+              <a:t>Procesamiento de </a:t>
             </a:r>
-            <a:endParaRPr lang="en-US" sz="3200" dirty="0"/>
-          </a:p>
-          <a:p>
-            <a:pPr marL="0" indent="0" algn="ctr">
-              <a:buNone/>
-            </a:pPr>
+            <a:r>
+              <a:rPr lang="en-US" sz="3200" b="1" dirty="0" err="1">
+                <a:solidFill>
+                  <a:srgbClr val="2A6B42"/>
+                </a:solidFill>
+              </a:rPr>
+              <a:t>datos</a:t>
+            </a:r>
             <a:r>
               <a:rPr lang="en-US" sz="3200" b="1" dirty="0">
                 <a:solidFill>
                   <a:srgbClr val="2A6B42"/>
                 </a:solidFill>
               </a:rPr>
-              <a:t>fuera de NADIA</a:t>
+              <a:t> </a:t>
+            </a:r>
+            <a:r>
+              <a:rPr lang="en-US" sz="3200" b="1" dirty="0" err="1">
+                <a:solidFill>
+                  <a:srgbClr val="2A6B42"/>
+                </a:solidFill>
+              </a:rPr>
+              <a:t>brutos</a:t>
             </a:r>
             <a:endParaRPr lang="en-US" sz="3200" dirty="0"/>
           </a:p>
@@ -834,6 +879,13 @@
               <a:prstDash val="solid"/>
             </a:ln>
           </p:spPr>
+          <p:txBody>
+            <a:bodyPr/>
+            <a:lstStyle/>
+            <a:p>
+              <a:endParaRPr lang="es-ES" sz="2000"/>
+            </a:p>
+          </p:txBody>
         </p:sp>
         <p:sp>
           <p:nvSpPr>
@@ -843,7 +895,7 @@
           </p:nvSpPr>
           <p:spPr>
             <a:xfrm>
-              <a:off x="548640" y="201168"/>
+              <a:off x="548640" y="223393"/>
               <a:ext cx="2011680" cy="292608"/>
             </a:xfrm>
             <a:prstGeom prst="rect">
@@ -860,14 +912,14 @@
                 <a:buNone/>
               </a:pPr>
               <a:r>
-                <a:rPr lang="en-US" sz="1400" b="1" dirty="0">
+                <a:rPr lang="en-US" sz="1600" b="1" dirty="0">
                   <a:solidFill>
                     <a:srgbClr val="1A4A2E"/>
                   </a:solidFill>
                 </a:rPr>
                 <a:t>Datos brutos</a:t>
               </a:r>
-              <a:endParaRPr lang="en-US" sz="1400" dirty="0"/>
+              <a:endParaRPr lang="en-US" sz="1600" dirty="0"/>
             </a:p>
           </p:txBody>
         </p:sp>
@@ -879,7 +931,7 @@
           </p:nvSpPr>
           <p:spPr>
             <a:xfrm>
-              <a:off x="548640" y="493776"/>
+              <a:off x="548640" y="439801"/>
               <a:ext cx="2011680" cy="256032"/>
             </a:xfrm>
             <a:prstGeom prst="rect">
@@ -896,14 +948,14 @@
                 <a:buNone/>
               </a:pPr>
               <a:r>
-                <a:rPr lang="en-US" sz="1050" dirty="0">
+                <a:rPr lang="en-US" sz="1100" dirty="0">
                   <a:solidFill>
                     <a:srgbClr val="2A6B42"/>
                   </a:solidFill>
                 </a:rPr>
                 <a:t>de nanoLC-MS/MS</a:t>
               </a:r>
-              <a:endParaRPr lang="en-US" sz="1050" dirty="0"/>
+              <a:endParaRPr lang="en-US" sz="1100" dirty="0"/>
             </a:p>
           </p:txBody>
         </p:sp>
@@ -931,6 +983,13 @@
             <a:tailEnd type="arrow"/>
           </a:ln>
         </p:spPr>
+        <p:txBody>
+          <a:bodyPr/>
+          <a:lstStyle/>
+          <a:p>
+            <a:endParaRPr lang="es-ES"/>
+          </a:p>
+        </p:txBody>
       </p:sp>
       <p:grpSp>
         <p:nvGrpSpPr>
@@ -978,6 +1037,13 @@
               <a:prstDash val="solid"/>
             </a:ln>
           </p:spPr>
+          <p:txBody>
+            <a:bodyPr/>
+            <a:lstStyle/>
+            <a:p>
+              <a:endParaRPr lang="es-ES" sz="2000"/>
+            </a:p>
+          </p:txBody>
         </p:sp>
         <p:sp>
           <p:nvSpPr>
@@ -987,7 +1053,7 @@
           </p:nvSpPr>
           <p:spPr>
             <a:xfrm>
-              <a:off x="548640" y="1069848"/>
+              <a:off x="548640" y="1111123"/>
               <a:ext cx="2011680" cy="274320"/>
             </a:xfrm>
             <a:prstGeom prst="rect">
@@ -1004,14 +1070,14 @@
                 <a:buNone/>
               </a:pPr>
               <a:r>
-                <a:rPr lang="en-US" sz="1400" b="1" dirty="0">
+                <a:rPr lang="en-US" sz="1600" b="1" dirty="0">
                   <a:solidFill>
                     <a:srgbClr val="1A4A2E"/>
                   </a:solidFill>
                 </a:rPr>
                 <a:t>Spectronaut</a:t>
               </a:r>
-              <a:endParaRPr lang="en-US" sz="1400" dirty="0"/>
+              <a:endParaRPr lang="en-US" sz="1600" dirty="0"/>
             </a:p>
           </p:txBody>
         </p:sp>
@@ -1023,7 +1089,7 @@
           </p:nvSpPr>
           <p:spPr>
             <a:xfrm>
-              <a:off x="548640" y="1344168"/>
+              <a:off x="548640" y="1312418"/>
               <a:ext cx="2011680" cy="256032"/>
             </a:xfrm>
             <a:prstGeom prst="rect">
@@ -1040,14 +1106,14 @@
                 <a:buNone/>
               </a:pPr>
               <a:r>
-                <a:rPr lang="en-US" sz="1050" dirty="0">
+                <a:rPr lang="en-US" sz="1100" dirty="0">
                   <a:solidFill>
                     <a:srgbClr val="2A6B42"/>
                   </a:solidFill>
                 </a:rPr>
                 <a:t>Inferencia de proteínas</a:t>
               </a:r>
-              <a:endParaRPr lang="en-US" sz="1050" dirty="0"/>
+              <a:endParaRPr lang="en-US" sz="1100" dirty="0"/>
             </a:p>
           </p:txBody>
         </p:sp>
@@ -1078,65 +1144,11 @@
             <a:prstDash val="solid"/>
           </a:ln>
         </p:spPr>
-      </p:sp>
-      <p:sp>
-        <p:nvSpPr>
-          <p:cNvPr id="14" name="circle_2"/>
-          <p:cNvSpPr/>
-          <p:nvPr/>
-        </p:nvSpPr>
-        <p:spPr>
-          <a:xfrm>
-            <a:off x="201168" y="2011680"/>
-            <a:ext cx="256032" cy="256032"/>
-          </a:xfrm>
-          <a:prstGeom prst="ellipse">
-            <a:avLst/>
-          </a:prstGeom>
-          <a:solidFill>
-            <a:srgbClr val="2A4A8A"/>
-          </a:solidFill>
-          <a:ln w="12700">
-            <a:solidFill>
-              <a:srgbClr val="2A4A8A"/>
-            </a:solidFill>
-            <a:prstDash val="solid"/>
-          </a:ln>
-        </p:spPr>
-      </p:sp>
-      <p:sp>
-        <p:nvSpPr>
-          <p:cNvPr id="15" name="label_2"/>
-          <p:cNvSpPr txBox="1"/>
-          <p:nvPr/>
-        </p:nvSpPr>
-        <p:spPr>
-          <a:xfrm>
-            <a:off x="201168" y="2011680"/>
-            <a:ext cx="256032" cy="256032"/>
-          </a:xfrm>
-          <a:prstGeom prst="rect">
-            <a:avLst/>
-          </a:prstGeom>
-          <a:noFill/>
-          <a:ln/>
-        </p:spPr>
         <p:txBody>
-          <a:bodyPr wrap="square" rtlCol="0" anchor="ctr"/>
+          <a:bodyPr/>
           <a:lstStyle/>
           <a:p>
-            <a:pPr marL="0" indent="0" algn="ctr">
-              <a:buNone/>
-            </a:pPr>
-            <a:r>
-              <a:rPr lang="en-US" sz="1100" b="1" dirty="0">
-                <a:solidFill>
-                  <a:srgbClr val="FFFFFF"/>
-                </a:solidFill>
-              </a:rPr>
-              <a:t>2</a:t>
-            </a:r>
-            <a:endParaRPr lang="en-US" sz="1100" dirty="0"/>
+            <a:endParaRPr lang="es-ES"/>
           </a:p>
         </p:txBody>
       </p:sp>
@@ -1148,8 +1160,8 @@
         </p:nvSpPr>
         <p:spPr>
           <a:xfrm>
-            <a:off x="4114800" y="2078058"/>
-            <a:ext cx="7315200" cy="320040"/>
+            <a:off x="6687724" y="2078058"/>
+            <a:ext cx="4934781" cy="274320"/>
           </a:xfrm>
           <a:prstGeom prst="rect">
             <a:avLst/>
@@ -1170,6 +1182,7 @@
             </a:lvl1pPr>
           </a:lstStyle>
           <a:p>
+            <a:pPr algn="r"/>
             <a:r>
               <a:rPr lang="en-US" dirty="0" err="1">
                 <a:solidFill>
@@ -1184,23 +1197,7 @@
                   <a:srgbClr val="1A3A6B"/>
                 </a:solidFill>
               </a:rPr>
-              <a:t> </a:t>
-            </a:r>
-            <a:r>
-              <a:rPr lang="en-US" dirty="0" err="1">
-                <a:solidFill>
-                  <a:srgbClr val="1A3A6B"/>
-                </a:solidFill>
-              </a:rPr>
-              <a:t>dependiente</a:t>
-            </a:r>
-            <a:r>
-              <a:rPr lang="en-US" dirty="0">
-                <a:solidFill>
-                  <a:srgbClr val="1A3A6B"/>
-                </a:solidFill>
-              </a:rPr>
-              <a:t> de NADIA</a:t>
+              <a:t> con NADIA</a:t>
             </a:r>
           </a:p>
         </p:txBody>
@@ -1251,6 +1248,13 @@
               <a:prstDash val="solid"/>
             </a:ln>
           </p:spPr>
+          <p:txBody>
+            <a:bodyPr/>
+            <a:lstStyle/>
+            <a:p>
+              <a:endParaRPr lang="es-ES" sz="2000"/>
+            </a:p>
+          </p:txBody>
         </p:sp>
         <p:sp>
           <p:nvSpPr>
@@ -1260,7 +1264,7 @@
           </p:nvSpPr>
           <p:spPr>
             <a:xfrm>
-              <a:off x="1188720" y="2176272"/>
+              <a:off x="1188720" y="2208022"/>
               <a:ext cx="2560320" cy="274320"/>
             </a:xfrm>
             <a:prstGeom prst="rect">
@@ -1277,14 +1281,14 @@
                 <a:buNone/>
               </a:pPr>
               <a:r>
-                <a:rPr lang="en-US" sz="1400" b="1" dirty="0">
+                <a:rPr lang="en-US" sz="1600" b="1" dirty="0">
                   <a:solidFill>
                     <a:srgbClr val="1A3A6B"/>
                   </a:solidFill>
                 </a:rPr>
                 <a:t>Preprocesamiento con NADIA</a:t>
               </a:r>
-              <a:endParaRPr lang="en-US" sz="1400" dirty="0"/>
+              <a:endParaRPr lang="en-US" sz="1600" dirty="0"/>
             </a:p>
           </p:txBody>
         </p:sp>
@@ -1313,14 +1317,14 @@
                 <a:buNone/>
               </a:pPr>
               <a:r>
-                <a:rPr lang="en-US" sz="1000" i="1" dirty="0">
+                <a:rPr lang="en-US" sz="1050" i="1" dirty="0">
                   <a:solidFill>
                     <a:srgbClr val="2A4A8A"/>
                   </a:solidFill>
                 </a:rPr>
                 <a:t>preprocessing_spectronaut()</a:t>
               </a:r>
-              <a:endParaRPr lang="en-US" sz="1000" dirty="0"/>
+              <a:endParaRPr lang="en-US" sz="1050" dirty="0"/>
             </a:p>
           </p:txBody>
         </p:sp>
@@ -1379,6 +1383,13 @@
             <a:tailEnd type="arrow"/>
           </a:ln>
         </p:spPr>
+        <p:txBody>
+          <a:bodyPr/>
+          <a:lstStyle/>
+          <a:p>
+            <a:endParaRPr lang="es-ES"/>
+          </a:p>
+        </p:txBody>
       </p:sp>
       <p:sp>
         <p:nvSpPr>
@@ -1388,8 +1399,8 @@
         </p:nvSpPr>
         <p:spPr>
           <a:xfrm>
-            <a:off x="6297424" y="2587743"/>
-            <a:ext cx="5224016" cy="914400"/>
+            <a:off x="6297424" y="2490872"/>
+            <a:ext cx="4781254" cy="1082222"/>
           </a:xfrm>
           <a:prstGeom prst="rect">
             <a:avLst/>
@@ -1401,11 +1412,11 @@
           <a:bodyPr wrap="square" rtlCol="0" anchor="t"/>
           <a:lstStyle/>
           <a:p>
-            <a:pPr marL="0" indent="0" algn="ctr">
+            <a:pPr marL="0" indent="0" algn="just">
               <a:buNone/>
             </a:pPr>
             <a:r>
-              <a:rPr lang="en-US" sz="1600" b="1" dirty="0">
+              <a:rPr lang="en-US" sz="1600" dirty="0">
                 <a:solidFill>
                   <a:srgbClr val="8A2060"/>
                 </a:solidFill>
@@ -1421,7 +1432,7 @@
               <a:t>función</a:t>
             </a:r>
             <a:r>
-              <a:rPr lang="en-US" sz="1600" b="1" dirty="0">
+              <a:rPr lang="en-US" sz="1600" dirty="0">
                 <a:solidFill>
                   <a:srgbClr val="8A2060"/>
                 </a:solidFill>
@@ -1429,7 +1440,7 @@
               <a:t> de </a:t>
             </a:r>
             <a:r>
-              <a:rPr lang="en-US" sz="1600" b="1" dirty="0" err="1">
+              <a:rPr lang="en-US" sz="1600" dirty="0" err="1">
                 <a:solidFill>
                   <a:srgbClr val="8A2060"/>
                 </a:solidFill>
@@ -1437,7 +1448,7 @@
               <a:t>análisis</a:t>
             </a:r>
             <a:r>
-              <a:rPr lang="en-US" sz="1600" b="1" dirty="0">
+              <a:rPr lang="en-US" sz="1600" dirty="0">
                 <a:solidFill>
                   <a:srgbClr val="8A2060"/>
                 </a:solidFill>
@@ -1445,7 +1456,7 @@
               <a:t> </a:t>
             </a:r>
             <a:r>
-              <a:rPr lang="en-US" sz="1600" b="1" dirty="0" err="1">
+              <a:rPr lang="en-US" sz="1600" dirty="0" err="1">
                 <a:solidFill>
                   <a:srgbClr val="8A2060"/>
                 </a:solidFill>
@@ -1453,28 +1464,12 @@
               <a:t>comparativo</a:t>
             </a:r>
             <a:r>
-              <a:rPr lang="en-US" sz="1600" b="1" dirty="0">
+              <a:rPr lang="en-US" sz="1600" dirty="0">
                 <a:solidFill>
                   <a:srgbClr val="8A2060"/>
                 </a:solidFill>
               </a:rPr>
-              <a:t> evalúa la </a:t>
-            </a:r>
-            <a:r>
-              <a:rPr lang="en-US" sz="1600" b="1" dirty="0" err="1">
-                <a:solidFill>
-                  <a:srgbClr val="8A2060"/>
-                </a:solidFill>
-              </a:rPr>
-              <a:t>salida</a:t>
-            </a:r>
-            <a:r>
-              <a:rPr lang="en-US" sz="1600" b="1" dirty="0">
-                <a:solidFill>
-                  <a:srgbClr val="8A2060"/>
-                </a:solidFill>
-              </a:rPr>
-              <a:t> de </a:t>
+              <a:t> evalúa la salida de </a:t>
             </a:r>
             <a:r>
               <a:rPr lang="en-US" sz="1600" b="1" i="1" dirty="0" err="1">
@@ -1485,7 +1480,7 @@
               <a:t>process_proteomics</a:t>
             </a:r>
             <a:r>
-              <a:rPr lang="en-US" sz="1600" b="1" i="1" dirty="0">
+              <a:rPr lang="en-US" sz="1600" i="1" dirty="0">
                 <a:solidFill>
                   <a:srgbClr val="8A2060"/>
                 </a:solidFill>
@@ -1493,12 +1488,28 @@
               <a:t>()</a:t>
             </a:r>
             <a:r>
+              <a:rPr lang="en-US" sz="1600" dirty="0">
+                <a:solidFill>
+                  <a:srgbClr val="8A2060"/>
+                </a:solidFill>
+              </a:rPr>
+              <a:t>. </a:t>
+            </a:r>
+            <a:r>
               <a:rPr lang="en-US" sz="1600" b="1" dirty="0">
                 <a:solidFill>
                   <a:srgbClr val="8A2060"/>
                 </a:solidFill>
               </a:rPr>
-              <a:t>. Valida los </a:t>
+              <a:t>Valida</a:t>
+            </a:r>
+            <a:r>
+              <a:rPr lang="en-US" sz="1600" dirty="0">
+                <a:solidFill>
+                  <a:srgbClr val="8A2060"/>
+                </a:solidFill>
+              </a:rPr>
+              <a:t> los </a:t>
             </a:r>
             <a:r>
               <a:rPr lang="en-US" sz="1600" b="1" dirty="0" err="1">
@@ -1509,7 +1520,7 @@
               <a:t>métodos</a:t>
             </a:r>
             <a:r>
-              <a:rPr lang="en-US" sz="1600" b="1" dirty="0">
+              <a:rPr lang="en-US" sz="1600" dirty="0">
                 <a:solidFill>
                   <a:srgbClr val="8A2060"/>
                 </a:solidFill>
@@ -1517,7 +1528,7 @@
               <a:t> de </a:t>
             </a:r>
             <a:r>
-              <a:rPr lang="en-US" sz="1600" b="1" dirty="0" err="1">
+              <a:rPr lang="en-US" sz="1600" dirty="0" err="1">
                 <a:solidFill>
                   <a:srgbClr val="8A2060"/>
                 </a:solidFill>
@@ -1525,7 +1536,7 @@
               <a:t>normalización</a:t>
             </a:r>
             <a:r>
-              <a:rPr lang="en-US" sz="1600" b="1" dirty="0">
+              <a:rPr lang="en-US" sz="1600" dirty="0">
                 <a:solidFill>
                   <a:srgbClr val="8A2060"/>
                 </a:solidFill>
@@ -1533,7 +1544,7 @@
               <a:t> e imputación MAR y es la </a:t>
             </a:r>
             <a:r>
-              <a:rPr lang="en-US" sz="1600" b="1" dirty="0" err="1">
+              <a:rPr lang="en-US" sz="1600" dirty="0" err="1">
                 <a:solidFill>
                   <a:srgbClr val="8A2060"/>
                 </a:solidFill>
@@ -1541,7 +1552,7 @@
               <a:t>única</a:t>
             </a:r>
             <a:r>
-              <a:rPr lang="en-US" sz="1600" b="1" dirty="0">
+              <a:rPr lang="en-US" sz="1600" dirty="0">
                 <a:solidFill>
                   <a:srgbClr val="8A2060"/>
                 </a:solidFill>
@@ -1549,7 +1560,7 @@
               <a:t> </a:t>
             </a:r>
             <a:r>
-              <a:rPr lang="en-US" sz="1600" b="1" dirty="0" err="1">
+              <a:rPr lang="en-US" sz="1600" dirty="0" err="1">
                 <a:solidFill>
                   <a:srgbClr val="8A2060"/>
                 </a:solidFill>
@@ -1557,7 +1568,7 @@
               <a:t>opción</a:t>
             </a:r>
             <a:r>
-              <a:rPr lang="en-US" sz="1600" b="1" dirty="0">
+              <a:rPr lang="en-US" sz="1600" dirty="0">
                 <a:solidFill>
                   <a:srgbClr val="8A2060"/>
                 </a:solidFill>
@@ -1565,7 +1576,7 @@
               <a:t> en NADIA para </a:t>
             </a:r>
             <a:r>
-              <a:rPr lang="en-US" sz="1600" b="1" dirty="0" err="1">
+              <a:rPr lang="en-US" sz="1600" dirty="0" err="1">
                 <a:solidFill>
                   <a:srgbClr val="8A2060"/>
                 </a:solidFill>
@@ -1573,7 +1584,7 @@
               <a:t>evaluar</a:t>
             </a:r>
             <a:r>
-              <a:rPr lang="en-US" sz="1600" b="1" dirty="0">
+              <a:rPr lang="en-US" sz="1600" dirty="0">
                 <a:solidFill>
                   <a:srgbClr val="8A2060"/>
                 </a:solidFill>
@@ -1581,7 +1592,7 @@
               <a:t> </a:t>
             </a:r>
             <a:r>
-              <a:rPr lang="en-US" sz="1600" b="1" dirty="0" err="1">
+              <a:rPr lang="en-US" sz="1600" dirty="0" err="1">
                 <a:solidFill>
                   <a:srgbClr val="8A2060"/>
                 </a:solidFill>
@@ -1589,7 +1600,7 @@
               <a:t>métodos</a:t>
             </a:r>
             <a:r>
-              <a:rPr lang="en-US" sz="1600" b="1" dirty="0">
+              <a:rPr lang="en-US" sz="1600" dirty="0">
                 <a:solidFill>
                   <a:srgbClr val="8A2060"/>
                 </a:solidFill>
@@ -1614,8 +1625,8 @@
         </p:nvGrpSpPr>
         <p:grpSpPr>
           <a:xfrm>
-            <a:off x="6638926" y="3814868"/>
-            <a:ext cx="3474720" cy="822960"/>
+            <a:off x="6638925" y="3665889"/>
+            <a:ext cx="3708767" cy="971939"/>
             <a:chOff x="5120640" y="3383280"/>
             <a:chExt cx="3474720" cy="822960"/>
           </a:xfrm>
@@ -1646,6 +1657,13 @@
               <a:prstDash val="dash"/>
             </a:ln>
           </p:spPr>
+          <p:txBody>
+            <a:bodyPr/>
+            <a:lstStyle/>
+            <a:p>
+              <a:endParaRPr lang="es-ES"/>
+            </a:p>
+          </p:txBody>
         </p:sp>
         <p:sp>
           <p:nvSpPr>
@@ -1677,7 +1695,47 @@
                     <a:srgbClr val="8A2A5A"/>
                   </a:solidFill>
                 </a:rPr>
-                <a:t>Cuando hay proteínas spike-in disponibles</a:t>
+                <a:t>Cuando hay </a:t>
+              </a:r>
+              <a:r>
+                <a:rPr lang="en-US" sz="900" i="1" dirty="0" err="1">
+                  <a:solidFill>
+                    <a:srgbClr val="8A2A5A"/>
+                  </a:solidFill>
+                </a:rPr>
+                <a:t>proteínas</a:t>
+              </a:r>
+              <a:r>
+                <a:rPr lang="en-US" sz="900" i="1" dirty="0">
+                  <a:solidFill>
+                    <a:srgbClr val="8A2A5A"/>
+                  </a:solidFill>
+                </a:rPr>
+                <a:t> de </a:t>
+              </a:r>
+              <a:r>
+                <a:rPr lang="en-US" sz="900" i="1" dirty="0" err="1">
+                  <a:solidFill>
+                    <a:srgbClr val="8A2A5A"/>
+                  </a:solidFill>
+                </a:rPr>
+                <a:t>referencia</a:t>
+              </a:r>
+              <a:r>
+                <a:rPr lang="en-US" sz="900" i="1" dirty="0">
+                  <a:solidFill>
+                    <a:srgbClr val="8A2A5A"/>
+                  </a:solidFill>
+                </a:rPr>
+                <a:t> </a:t>
+              </a:r>
+              <a:r>
+                <a:rPr lang="en-US" sz="900" i="1" dirty="0" err="1">
+                  <a:solidFill>
+                    <a:srgbClr val="8A2A5A"/>
+                  </a:solidFill>
+                </a:rPr>
+                <a:t>disponibles</a:t>
               </a:r>
               <a:endParaRPr lang="en-US" sz="900" dirty="0"/>
             </a:p>
@@ -1708,14 +1766,38 @@
                 <a:buNone/>
               </a:pPr>
               <a:r>
-                <a:rPr lang="en-US" sz="1400" b="1" dirty="0">
+                <a:rPr lang="en-US" sz="1600" b="1" dirty="0">
                   <a:solidFill>
                     <a:srgbClr val="8A2060"/>
                   </a:solidFill>
                 </a:rPr>
-                <a:t>Benchmarking con proteínas spike-in</a:t>
-              </a:r>
-              <a:endParaRPr lang="en-US" sz="1400" dirty="0"/>
+                <a:t>Benchmarking con </a:t>
+              </a:r>
+              <a:r>
+                <a:rPr lang="en-US" sz="1600" b="1" dirty="0" err="1">
+                  <a:solidFill>
+                    <a:srgbClr val="8A2060"/>
+                  </a:solidFill>
+                </a:rPr>
+                <a:t>proteínas</a:t>
+              </a:r>
+              <a:r>
+                <a:rPr lang="en-US" sz="1600" b="1" dirty="0">
+                  <a:solidFill>
+                    <a:srgbClr val="8A2060"/>
+                  </a:solidFill>
+                </a:rPr>
+                <a:t> de </a:t>
+              </a:r>
+              <a:r>
+                <a:rPr lang="en-US" sz="1600" b="1" dirty="0" err="1">
+                  <a:solidFill>
+                    <a:srgbClr val="8A2060"/>
+                  </a:solidFill>
+                </a:rPr>
+                <a:t>referencia</a:t>
+              </a:r>
+              <a:endParaRPr lang="en-US" sz="1600" dirty="0"/>
             </a:p>
           </p:txBody>
         </p:sp>
@@ -1744,28 +1826,28 @@
                 <a:buNone/>
               </a:pPr>
               <a:r>
-                <a:rPr lang="en-US" sz="1000" i="1" dirty="0">
+                <a:rPr lang="en-US" sz="1050" i="1" dirty="0">
                   <a:solidFill>
                     <a:srgbClr val="8A2A5A"/>
                   </a:solidFill>
                 </a:rPr>
                 <a:t>benchmarking_proteomics()</a:t>
               </a:r>
-              <a:endParaRPr lang="en-US" sz="1000" dirty="0"/>
+              <a:endParaRPr lang="en-US" sz="1050" dirty="0"/>
             </a:p>
             <a:p>
               <a:pPr marL="0" indent="0" algn="ctr">
                 <a:buNone/>
               </a:pPr>
               <a:r>
-                <a:rPr lang="en-US" sz="1000" i="1" dirty="0">
+                <a:rPr lang="en-US" sz="1050" i="1" dirty="0">
                   <a:solidFill>
                     <a:srgbClr val="8A2A5A"/>
                   </a:solidFill>
                 </a:rPr>
                 <a:t>benchmarking_multiple()</a:t>
               </a:r>
-              <a:endParaRPr lang="en-US" sz="1000" dirty="0"/>
+              <a:endParaRPr lang="en-US" sz="1050" dirty="0"/>
             </a:p>
           </p:txBody>
         </p:sp>
@@ -1816,6 +1898,13 @@
               <a:prstDash val="solid"/>
             </a:ln>
           </p:spPr>
+          <p:txBody>
+            <a:bodyPr/>
+            <a:lstStyle/>
+            <a:p>
+              <a:endParaRPr lang="es-ES"/>
+            </a:p>
+          </p:txBody>
         </p:sp>
         <p:sp>
           <p:nvSpPr>
@@ -1878,14 +1967,14 @@
                 <a:buNone/>
               </a:pPr>
               <a:r>
-                <a:rPr lang="en-US" sz="1000" i="1" dirty="0">
+                <a:rPr lang="en-US" sz="1100" i="1" dirty="0">
                   <a:solidFill>
                     <a:srgbClr val="2A4A8A"/>
                   </a:solidFill>
                 </a:rPr>
                 <a:t>process_proteomics()</a:t>
               </a:r>
-              <a:endParaRPr lang="en-US" sz="1000" dirty="0"/>
+              <a:endParaRPr lang="en-US" sz="1100" dirty="0"/>
             </a:p>
           </p:txBody>
         </p:sp>
@@ -1913,6 +2002,13 @@
             <a:tailEnd type="arrow"/>
           </a:ln>
         </p:spPr>
+        <p:txBody>
+          <a:bodyPr/>
+          <a:lstStyle/>
+          <a:p>
+            <a:endParaRPr lang="es-ES"/>
+          </a:p>
+        </p:txBody>
       </p:sp>
       <p:sp>
         <p:nvSpPr>
@@ -1989,28 +2085,28 @@
               <a:buNone/>
             </a:pPr>
             <a:r>
-              <a:rPr lang="en-US" sz="1100" dirty="0">
+              <a:rPr lang="en-US" sz="1200" dirty="0">
                 <a:solidFill>
                   <a:srgbClr val="1A3A6B"/>
                 </a:solidFill>
               </a:rPr>
               <a:t>Métodos de normalización e</a:t>
             </a:r>
-            <a:endParaRPr lang="en-US" sz="1100" dirty="0"/>
+            <a:endParaRPr lang="en-US" sz="1200" dirty="0"/>
           </a:p>
           <a:p>
             <a:pPr marL="0" indent="0" algn="ctr">
               <a:buNone/>
             </a:pPr>
             <a:r>
-              <a:rPr lang="en-US" sz="1100" dirty="0">
+              <a:rPr lang="en-US" sz="1200" dirty="0">
                 <a:solidFill>
                   <a:srgbClr val="1A3A6B"/>
                 </a:solidFill>
               </a:rPr>
               <a:t>imputación seleccionados</a:t>
             </a:r>
-            <a:endParaRPr lang="en-US" sz="1100" dirty="0"/>
+            <a:endParaRPr lang="en-US" sz="1200" dirty="0"/>
           </a:p>
         </p:txBody>
       </p:sp>
@@ -2060,6 +2156,13 @@
               <a:prstDash val="solid"/>
             </a:ln>
           </p:spPr>
+          <p:txBody>
+            <a:bodyPr/>
+            <a:lstStyle/>
+            <a:p>
+              <a:endParaRPr lang="es-ES"/>
+            </a:p>
+          </p:txBody>
         </p:sp>
         <p:sp>
           <p:nvSpPr>
@@ -2086,14 +2189,14 @@
                 <a:buNone/>
               </a:pPr>
               <a:r>
-                <a:rPr lang="en-US" sz="1600" b="1" dirty="0">
+                <a:rPr lang="en-US" b="1" dirty="0">
                   <a:solidFill>
                     <a:srgbClr val="1A3A6B"/>
                   </a:solidFill>
                 </a:rPr>
                 <a:t>Análisis funcional</a:t>
               </a:r>
-              <a:endParaRPr lang="en-US" sz="1600" dirty="0"/>
+              <a:endParaRPr lang="en-US" dirty="0"/>
             </a:p>
           </p:txBody>
         </p:sp>
@@ -2144,6 +2247,13 @@
               <a:prstDash val="dash"/>
             </a:ln>
           </p:spPr>
+          <p:txBody>
+            <a:bodyPr/>
+            <a:lstStyle/>
+            <a:p>
+              <a:endParaRPr lang="es-ES"/>
+            </a:p>
+          </p:txBody>
         </p:sp>
         <p:sp>
           <p:nvSpPr>
@@ -2153,7 +2263,7 @@
           </p:nvSpPr>
           <p:spPr>
             <a:xfrm>
-              <a:off x="8961120" y="5321808"/>
+              <a:off x="8961120" y="5350683"/>
               <a:ext cx="2560320" cy="320040"/>
             </a:xfrm>
             <a:prstGeom prst="rect">
@@ -2170,14 +2280,14 @@
                 <a:buNone/>
               </a:pPr>
               <a:r>
-                <a:rPr lang="en-US" sz="1600" b="1" dirty="0">
+                <a:rPr lang="en-US" b="1" dirty="0">
                   <a:solidFill>
                     <a:srgbClr val="1A3A6B"/>
                   </a:solidFill>
                 </a:rPr>
                 <a:t>Perfilado de patrones</a:t>
               </a:r>
-              <a:endParaRPr lang="en-US" sz="1600" dirty="0"/>
+              <a:endParaRPr lang="en-US" dirty="0"/>
             </a:p>
           </p:txBody>
         </p:sp>
@@ -2241,6 +2351,13 @@
             <a:tailEnd type="arrow"/>
           </a:ln>
         </p:spPr>
+        <p:txBody>
+          <a:bodyPr/>
+          <a:lstStyle/>
+          <a:p>
+            <a:endParaRPr lang="es-ES"/>
+          </a:p>
+        </p:txBody>
       </p:sp>
       <p:sp>
         <p:nvSpPr>
@@ -2302,6 +2419,13 @@
             <a:tailEnd type="arrow"/>
           </a:ln>
         </p:spPr>
+        <p:txBody>
+          <a:bodyPr/>
+          <a:lstStyle/>
+          <a:p>
+            <a:endParaRPr lang="es-ES"/>
+          </a:p>
+        </p:txBody>
       </p:sp>
       <p:grpSp>
         <p:nvGrpSpPr>
@@ -2349,6 +2473,13 @@
               <a:prstDash val="solid"/>
             </a:ln>
           </p:spPr>
+          <p:txBody>
+            <a:bodyPr/>
+            <a:lstStyle/>
+            <a:p>
+              <a:endParaRPr lang="es-ES"/>
+            </a:p>
+          </p:txBody>
         </p:sp>
         <p:sp>
           <p:nvSpPr>
@@ -2375,7 +2506,7 @@
                 <a:buNone/>
               </a:pPr>
               <a:r>
-                <a:rPr lang="en-US" sz="1400" b="1" dirty="0">
+                <a:rPr lang="en-US" sz="1600" b="1" dirty="0">
                   <a:solidFill>
                     <a:srgbClr val="1A3A6B"/>
                   </a:solidFill>
@@ -2383,7 +2514,7 @@
                 <a:t>Análisis de </a:t>
               </a:r>
               <a:r>
-                <a:rPr lang="en-US" sz="1400" b="1" dirty="0" err="1">
+                <a:rPr lang="en-US" sz="1600" b="1" dirty="0" err="1">
                   <a:solidFill>
                     <a:srgbClr val="1A3A6B"/>
                   </a:solidFill>
@@ -2391,14 +2522,14 @@
                 <a:t>métricas</a:t>
               </a:r>
               <a:r>
-                <a:rPr lang="en-US" sz="1400" b="1" dirty="0">
+                <a:rPr lang="en-US" sz="1600" b="1" dirty="0">
                   <a:solidFill>
                     <a:srgbClr val="1A3A6B"/>
                   </a:solidFill>
                 </a:rPr>
                 <a:t> de normalización</a:t>
               </a:r>
-              <a:endParaRPr lang="en-US" sz="1400" dirty="0"/>
+              <a:endParaRPr lang="en-US" sz="1600" dirty="0"/>
             </a:p>
           </p:txBody>
         </p:sp>
@@ -2410,7 +2541,7 @@
           </p:nvSpPr>
           <p:spPr>
             <a:xfrm>
-              <a:off x="347472" y="3813048"/>
+              <a:off x="347472" y="3880423"/>
               <a:ext cx="2103120" cy="320040"/>
             </a:xfrm>
             <a:prstGeom prst="rect">
@@ -2499,6 +2630,13 @@
               <a:prstDash val="solid"/>
             </a:ln>
           </p:spPr>
+          <p:txBody>
+            <a:bodyPr/>
+            <a:lstStyle/>
+            <a:p>
+              <a:endParaRPr lang="es-ES"/>
+            </a:p>
+          </p:txBody>
         </p:sp>
         <p:sp>
           <p:nvSpPr>
@@ -2525,7 +2663,7 @@
                 <a:buNone/>
               </a:pPr>
               <a:r>
-                <a:rPr lang="en-US" sz="1400" b="1" dirty="0">
+                <a:rPr lang="en-US" sz="1600" b="1" dirty="0">
                   <a:solidFill>
                     <a:srgbClr val="1A3A6B"/>
                   </a:solidFill>
@@ -2533,7 +2671,7 @@
                 <a:t>Análisis de </a:t>
               </a:r>
               <a:r>
-                <a:rPr lang="en-US" sz="1400" b="1" dirty="0" err="1">
+                <a:rPr lang="en-US" sz="1600" b="1" dirty="0" err="1">
                   <a:solidFill>
                     <a:srgbClr val="1A3A6B"/>
                   </a:solidFill>
@@ -2541,12 +2679,12 @@
                 <a:t>métricas</a:t>
               </a:r>
               <a:r>
-                <a:rPr lang="en-US" sz="1400" b="1" dirty="0">
+                <a:rPr lang="en-US" sz="1600" b="1" dirty="0">
                   <a:solidFill>
                     <a:srgbClr val="1A3A6B"/>
                   </a:solidFill>
                 </a:rPr>
-                <a:t> de </a:t>
+                <a:t> </a:t>
               </a:r>
             </a:p>
             <a:p>
@@ -2554,14 +2692,22 @@
                 <a:buNone/>
               </a:pPr>
               <a:r>
-                <a:rPr lang="en-US" sz="1400" b="1" dirty="0" err="1">
+                <a:rPr lang="en-US" sz="1600" b="1" dirty="0">
                   <a:solidFill>
                     <a:srgbClr val="1A3A6B"/>
                   </a:solidFill>
                 </a:rPr>
+                <a:t>de </a:t>
+              </a:r>
+              <a:r>
+                <a:rPr lang="en-US" sz="1600" b="1" dirty="0" err="1">
+                  <a:solidFill>
+                    <a:srgbClr val="1A3A6B"/>
+                  </a:solidFill>
+                </a:rPr>
                 <a:t>imputación</a:t>
               </a:r>
-              <a:endParaRPr lang="en-US" sz="1400" dirty="0"/>
+              <a:endParaRPr lang="en-US" sz="1600" dirty="0"/>
             </a:p>
           </p:txBody>
         </p:sp>
@@ -2573,7 +2719,7 @@
           </p:nvSpPr>
           <p:spPr>
             <a:xfrm>
-              <a:off x="3129281" y="3721608"/>
+              <a:off x="3129281" y="3740858"/>
               <a:ext cx="2286000" cy="201168"/>
             </a:xfrm>
             <a:prstGeom prst="rect">
@@ -2726,6 +2872,107 @@
           </a:p>
         </p:txBody>
       </p:sp>
+      <p:grpSp>
+        <p:nvGrpSpPr>
+          <p:cNvPr id="62" name="Group 61">
+            <a:extLst>
+              <a:ext uri="{FF2B5EF4-FFF2-40B4-BE49-F238E27FC236}">
+                <a16:creationId xmlns:a16="http://schemas.microsoft.com/office/drawing/2014/main" id="{39E00A3A-6005-2279-AE6D-BAB7A77450DC}"/>
+              </a:ext>
+            </a:extLst>
+          </p:cNvPr>
+          <p:cNvGrpSpPr/>
+          <p:nvPr/>
+        </p:nvGrpSpPr>
+        <p:grpSpPr>
+          <a:xfrm>
+            <a:off x="224365" y="2012908"/>
+            <a:ext cx="395732" cy="404241"/>
+            <a:chOff x="201168" y="155448"/>
+            <a:chExt cx="256032" cy="256032"/>
+          </a:xfrm>
+        </p:grpSpPr>
+        <p:sp>
+          <p:nvSpPr>
+            <p:cNvPr id="63" name="circle_1">
+              <a:extLst>
+                <a:ext uri="{FF2B5EF4-FFF2-40B4-BE49-F238E27FC236}">
+                  <a16:creationId xmlns:a16="http://schemas.microsoft.com/office/drawing/2014/main" id="{26196404-1AB3-B4AB-2A97-4769E309C05A}"/>
+                </a:ext>
+              </a:extLst>
+            </p:cNvPr>
+            <p:cNvSpPr/>
+            <p:nvPr/>
+          </p:nvSpPr>
+          <p:spPr>
+            <a:xfrm>
+              <a:off x="201168" y="155448"/>
+              <a:ext cx="256032" cy="256032"/>
+            </a:xfrm>
+            <a:prstGeom prst="ellipse">
+              <a:avLst/>
+            </a:prstGeom>
+            <a:solidFill>
+              <a:srgbClr val="2A4A8A"/>
+            </a:solidFill>
+            <a:ln w="12700">
+              <a:solidFill>
+                <a:srgbClr val="2A4A8A"/>
+              </a:solidFill>
+              <a:prstDash val="solid"/>
+            </a:ln>
+          </p:spPr>
+          <p:txBody>
+            <a:bodyPr/>
+            <a:lstStyle/>
+            <a:p>
+              <a:endParaRPr lang="es-ES"/>
+            </a:p>
+          </p:txBody>
+        </p:sp>
+        <p:sp>
+          <p:nvSpPr>
+            <p:cNvPr id="64" name="label_1">
+              <a:extLst>
+                <a:ext uri="{FF2B5EF4-FFF2-40B4-BE49-F238E27FC236}">
+                  <a16:creationId xmlns:a16="http://schemas.microsoft.com/office/drawing/2014/main" id="{1CD0B602-5701-CB9B-B2ED-E00DCE94B197}"/>
+                </a:ext>
+              </a:extLst>
+            </p:cNvPr>
+            <p:cNvSpPr txBox="1"/>
+            <p:nvPr/>
+          </p:nvSpPr>
+          <p:spPr>
+            <a:xfrm>
+              <a:off x="201168" y="155448"/>
+              <a:ext cx="256032" cy="256032"/>
+            </a:xfrm>
+            <a:prstGeom prst="rect">
+              <a:avLst/>
+            </a:prstGeom>
+            <a:noFill/>
+            <a:ln/>
+          </p:spPr>
+          <p:txBody>
+            <a:bodyPr wrap="square" rtlCol="0" anchor="ctr"/>
+            <a:lstStyle/>
+            <a:p>
+              <a:pPr marL="0" indent="0" algn="ctr">
+                <a:buNone/>
+              </a:pPr>
+              <a:r>
+                <a:rPr lang="en-US" sz="2000" b="1" dirty="0">
+                  <a:solidFill>
+                    <a:srgbClr val="FFFFFF"/>
+                  </a:solidFill>
+                </a:rPr>
+                <a:t>2</a:t>
+              </a:r>
+              <a:endParaRPr lang="en-US" sz="2000" dirty="0"/>
+            </a:p>
+          </p:txBody>
+        </p:sp>
+      </p:grpSp>
     </p:spTree>
   </p:cSld>
   <p:clrMapOvr>

</xml_diff>